<commit_message>
Update Power Platform DevOps ALM presentation file
</commit_message>
<xml_diff>
--- a/Media/Power Platform DevOps ALM_DevOps_April2025.pptx
+++ b/Media/Power Platform DevOps ALM_DevOps_April2025.pptx
@@ -17555,7 +17555,7 @@
           <a:p>
             <a:fld id="{F3D94F0C-0140-4943-BDC7-E14B7DFA33E3}" type="datetimeFigureOut">
               <a:rPr lang="en-GB" smtClean="0"/>
-              <a:t>23/04/2026</a:t>
+              <a:t>24/04/2026</a:t>
             </a:fld>
             <a:endParaRPr lang="en-GB"/>
           </a:p>
@@ -19077,7 +19077,7 @@
           <a:p>
             <a:fld id="{33031477-93FF-423B-B360-5C5FD20D6824}" type="datetimeFigureOut">
               <a:rPr lang="en-GB" smtClean="0"/>
-              <a:t>23/04/2026</a:t>
+              <a:t>24/04/2026</a:t>
             </a:fld>
             <a:endParaRPr lang="en-GB"/>
           </a:p>
@@ -19301,7 +19301,7 @@
           <a:p>
             <a:fld id="{33031477-93FF-423B-B360-5C5FD20D6824}" type="datetimeFigureOut">
               <a:rPr lang="en-GB" smtClean="0"/>
-              <a:t>23/04/2026</a:t>
+              <a:t>24/04/2026</a:t>
             </a:fld>
             <a:endParaRPr lang="en-GB"/>
           </a:p>
@@ -19535,7 +19535,7 @@
           <a:p>
             <a:fld id="{33031477-93FF-423B-B360-5C5FD20D6824}" type="datetimeFigureOut">
               <a:rPr lang="en-GB" smtClean="0"/>
-              <a:t>23/04/2026</a:t>
+              <a:t>24/04/2026</a:t>
             </a:fld>
             <a:endParaRPr lang="en-GB"/>
           </a:p>
@@ -20980,7 +20980,7 @@
           <a:p>
             <a:fld id="{33031477-93FF-423B-B360-5C5FD20D6824}" type="datetimeFigureOut">
               <a:rPr lang="en-GB" smtClean="0"/>
-              <a:t>23/04/2026</a:t>
+              <a:t>24/04/2026</a:t>
             </a:fld>
             <a:endParaRPr lang="en-GB"/>
           </a:p>
@@ -21146,7 +21146,7 @@
           <a:p>
             <a:fld id="{33031477-93FF-423B-B360-5C5FD20D6824}" type="datetimeFigureOut">
               <a:rPr lang="en-GB" smtClean="0"/>
-              <a:t>23/04/2026</a:t>
+              <a:t>24/04/2026</a:t>
             </a:fld>
             <a:endParaRPr lang="en-GB"/>
           </a:p>
@@ -21283,7 +21283,7 @@
           <a:p>
             <a:fld id="{33031477-93FF-423B-B360-5C5FD20D6824}" type="datetimeFigureOut">
               <a:rPr lang="en-GB" smtClean="0"/>
-              <a:t>23/04/2026</a:t>
+              <a:t>24/04/2026</a:t>
             </a:fld>
             <a:endParaRPr lang="en-GB"/>
           </a:p>
@@ -21620,7 +21620,7 @@
           <a:p>
             <a:fld id="{33031477-93FF-423B-B360-5C5FD20D6824}" type="datetimeFigureOut">
               <a:rPr lang="en-GB" smtClean="0"/>
-              <a:t>23/04/2026</a:t>
+              <a:t>24/04/2026</a:t>
             </a:fld>
             <a:endParaRPr lang="en-GB"/>
           </a:p>
@@ -34251,14 +34251,14 @@
           <p:nvPr>
             <p:extLst>
               <p:ext uri="{D42A27DB-BD31-4B8C-83A1-F6EECF244321}">
-                <p14:modId xmlns:p14="http://schemas.microsoft.com/office/powerpoint/2010/main" val="2643504632"/>
+                <p14:modId xmlns:p14="http://schemas.microsoft.com/office/powerpoint/2010/main" val="4192510251"/>
               </p:ext>
             </p:extLst>
           </p:nvPr>
         </p:nvGraphicFramePr>
         <p:xfrm>
           <a:off x="718350" y="1269380"/>
-          <a:ext cx="7812116" cy="3708400"/>
+          <a:ext cx="5581866" cy="3708400"/>
         </p:xfrm>
         <a:graphic>
           <a:graphicData uri="http://schemas.openxmlformats.org/drawingml/2006/table">
@@ -34281,7 +34281,7 @@
                     </a:ext>
                   </a:extLst>
                 </a:gridCol>
-                <a:gridCol w="6198095">
+                <a:gridCol w="3967845">
                   <a:extLst>
                     <a:ext uri="{9D8B030D-6E8A-4147-A177-3AD203B41FA5}">
                       <a16:colId xmlns:a16="http://schemas.microsoft.com/office/drawing/2014/main" val="3703844435"/>
@@ -34897,6 +34897,77 @@
           </a:graphicData>
         </a:graphic>
       </p:graphicFrame>
+      <p:pic>
+        <p:nvPicPr>
+          <p:cNvPr id="4" name="Picture 3">
+            <a:extLst>
+              <a:ext uri="{FF2B5EF4-FFF2-40B4-BE49-F238E27FC236}">
+                <a16:creationId xmlns:a16="http://schemas.microsoft.com/office/drawing/2014/main" id="{B7B827C0-5C23-C1EA-5A53-D021BEDE03F2}"/>
+              </a:ext>
+            </a:extLst>
+          </p:cNvPr>
+          <p:cNvPicPr>
+            <a:picLocks noChangeAspect="1"/>
+          </p:cNvPicPr>
+          <p:nvPr/>
+        </p:nvPicPr>
+        <p:blipFill>
+          <a:blip r:embed="rId3">
+            <a:extLst>
+              <a:ext uri="{28A0092B-C50C-407E-A947-70E740481C1C}">
+                <a14:useLocalDpi xmlns:a14="http://schemas.microsoft.com/office/drawing/2010/main" val="0"/>
+              </a:ext>
+            </a:extLst>
+          </a:blip>
+          <a:stretch>
+            <a:fillRect/>
+          </a:stretch>
+        </p:blipFill>
+        <p:spPr>
+          <a:xfrm>
+            <a:off x="7572947" y="1269380"/>
+            <a:ext cx="3436430" cy="3436430"/>
+          </a:xfrm>
+          <a:prstGeom prst="rect">
+            <a:avLst/>
+          </a:prstGeom>
+        </p:spPr>
+      </p:pic>
+      <p:sp>
+        <p:nvSpPr>
+          <p:cNvPr id="5" name="TextBox 4">
+            <a:extLst>
+              <a:ext uri="{FF2B5EF4-FFF2-40B4-BE49-F238E27FC236}">
+                <a16:creationId xmlns:a16="http://schemas.microsoft.com/office/drawing/2014/main" id="{3CD12591-9D6B-A822-51D9-59686DEDD68D}"/>
+              </a:ext>
+            </a:extLst>
+          </p:cNvPr>
+          <p:cNvSpPr txBox="1"/>
+          <p:nvPr/>
+        </p:nvSpPr>
+        <p:spPr>
+          <a:xfrm>
+            <a:off x="7434724" y="4977780"/>
+            <a:ext cx="3712876" cy="369332"/>
+          </a:xfrm>
+          <a:prstGeom prst="rect">
+            <a:avLst/>
+          </a:prstGeom>
+          <a:noFill/>
+        </p:spPr>
+        <p:txBody>
+          <a:bodyPr wrap="none" rtlCol="0">
+            <a:spAutoFit/>
+          </a:bodyPr>
+          <a:lstStyle/>
+          <a:p>
+            <a:r>
+              <a:rPr lang="en-GB" b="1" dirty="0"/>
+              <a:t>https://tinyurl.com/ppdobc2026</a:t>
+            </a:r>
+          </a:p>
+        </p:txBody>
+      </p:sp>
     </p:spTree>
     <p:extLst>
       <p:ext uri="{BB962C8B-B14F-4D97-AF65-F5344CB8AC3E}">

</xml_diff>